<commit_message>
sd-07 decks: state conditions and examples as the lessons do (016, 019, 004, 007, 011, 012, 018, 020)
Co-Authored-By: Claude Sonnet 5.5 <noreply@anthropic.com>
Claude-Session: https://claude.ai/code/session_01BtjRnkmJACkCsB95njaf7c
</commit_message>
<xml_diff>
--- a/system-design-101/vi/lessons/sd-07-004/slides/sd-07-004.pptx
+++ b/system-design-101/vi/lessons/sd-07-004/slides/sd-07-004.pptx
@@ -5125,6 +5125,83 @@
               <a:buNone/>
             </a:pPr>
             <a:r>
+              <a:rPr lang="en-US" sz="2700" b="1" dirty="0" spc="1" kern="0">
+                <a:solidFill>
+                  <a:srgbClr val="14161C"/>
+                </a:solidFill>
+                <a:latin typeface="Be Vietnam Pro" pitchFamily="34" charset="0"/>
+                <a:ea typeface="Be Vietnam Pro" pitchFamily="34" charset="-122"/>
+                <a:cs typeface="Be Vietnam Pro" pitchFamily="34" charset="-120"/>
+              </a:rPr>
+              <a:t>Ý</a:t>
+            </a:r>
+            <a:r>
+              <a:rPr lang="en-US" sz="2700" b="1" dirty="0" spc="6" kern="0">
+                <a:solidFill>
+                  <a:srgbClr val="14161C"/>
+                </a:solidFill>
+                <a:latin typeface="Be Vietnam Pro" pitchFamily="34" charset="0"/>
+                <a:ea typeface="Be Vietnam Pro" pitchFamily="34" charset="-122"/>
+                <a:cs typeface="Be Vietnam Pro" pitchFamily="34" charset="-120"/>
+              </a:rPr>
+              <a:t> tưởng:</a:t>
+            </a:r>
+            <a:r>
+              <a:rPr lang="en-US" sz="2700" b="1" dirty="0" spc="0" kern="0">
+                <a:solidFill>
+                  <a:srgbClr val="14161C"/>
+                </a:solidFill>
+                <a:latin typeface="Be Vietnam Pro" pitchFamily="34" charset="0"/>
+                <a:ea typeface="Be Vietnam Pro" pitchFamily="34" charset="-122"/>
+                <a:cs typeface="Be Vietnam Pro" pitchFamily="34" charset="-120"/>
+              </a:rPr>
+              <a:t> đọc,</a:t>
+            </a:r>
+            <a:r>
+              <a:rPr lang="en-US" sz="2700" b="1" dirty="0" spc="-5" kern="0">
+                <a:solidFill>
+                  <a:srgbClr val="14161C"/>
+                </a:solidFill>
+                <a:latin typeface="Be Vietnam Pro" pitchFamily="34" charset="0"/>
+                <a:ea typeface="Be Vietnam Pro" pitchFamily="34" charset="-122"/>
+                <a:cs typeface="Be Vietnam Pro" pitchFamily="34" charset="-120"/>
+              </a:rPr>
+              <a:t> viết, sở</a:t>
+            </a:r>
+            <a:r>
+              <a:rPr lang="en-US" sz="2700" b="1" dirty="0" spc="28" kern="0">
+                <a:solidFill>
+                  <a:srgbClr val="14161C"/>
+                </a:solidFill>
+                <a:latin typeface="Be Vietnam Pro" pitchFamily="34" charset="0"/>
+                <a:ea typeface="Be Vietnam Pro" pitchFamily="34" charset="-122"/>
+                <a:cs typeface="Be Vietnam Pro" pitchFamily="34" charset="-120"/>
+              </a:rPr>
+              <a:t> hữu;</a:t>
+            </a:r>
+            <a:r>
+              <a:rPr lang="en-US" sz="2700" b="1" dirty="0" spc="-1" kern="0">
+                <a:solidFill>
+                  <a:srgbClr val="14161C"/>
+                </a:solidFill>
+                <a:latin typeface="Be Vietnam Pro" pitchFamily="34" charset="0"/>
+                <a:ea typeface="Be Vietnam Pro" pitchFamily="34" charset="-122"/>
+                <a:cs typeface="Be Vietnam Pro" pitchFamily="34" charset="-120"/>
+              </a:rPr>
+              <a:t> dữ</a:t>
+            </a:r>
+            <a:r>
+              <a:rPr lang="en-US" sz="2700" b="1" dirty="0" spc="1" kern="0">
+                <a:solidFill>
+                  <a:srgbClr val="14161C"/>
+                </a:solidFill>
+                <a:latin typeface="Be Vietnam Pro" pitchFamily="34" charset="0"/>
+                <a:ea typeface="Be Vietnam Pro" pitchFamily="34" charset="-122"/>
+                <a:cs typeface="Be Vietnam Pro" pitchFamily="34" charset="-120"/>
+              </a:rPr>
+              <a:t> liệu</a:t>
+            </a:r>
+            <a:r>
               <a:rPr lang="en-US" sz="2700" b="1" dirty="0" spc="-3" kern="0">
                 <a:solidFill>
                   <a:srgbClr val="14161C"/>
@@ -5133,98 +5210,21 @@
                 <a:ea typeface="Be Vietnam Pro" pitchFamily="34" charset="-122"/>
                 <a:cs typeface="Be Vietnam Pro" pitchFamily="34" charset="-120"/>
               </a:rPr>
-              <a:t>Đọc,</a:t>
-            </a:r>
-            <a:r>
-              <a:rPr lang="en-US" sz="2700" b="1" dirty="0" spc="-5" kern="0">
-                <a:solidFill>
-                  <a:srgbClr val="14161C"/>
-                </a:solidFill>
-                <a:latin typeface="Be Vietnam Pro" pitchFamily="34" charset="0"/>
-                <a:ea typeface="Be Vietnam Pro" pitchFamily="34" charset="-122"/>
-                <a:cs typeface="Be Vietnam Pro" pitchFamily="34" charset="-120"/>
-              </a:rPr>
-              <a:t> viết</a:t>
-            </a:r>
-            <a:r>
-              <a:rPr lang="en-US" sz="2700" b="1" dirty="0" spc="-23" kern="0">
-                <a:solidFill>
-                  <a:srgbClr val="14161C"/>
-                </a:solidFill>
-                <a:latin typeface="Be Vietnam Pro" pitchFamily="34" charset="0"/>
-                <a:ea typeface="Be Vietnam Pro" pitchFamily="34" charset="-122"/>
-                <a:cs typeface="Be Vietnam Pro" pitchFamily="34" charset="-120"/>
-              </a:rPr>
-              <a:t> và</a:t>
-            </a:r>
-            <a:r>
-              <a:rPr lang="en-US" sz="2700" b="1" dirty="0" spc="-5" kern="0">
-                <a:solidFill>
-                  <a:srgbClr val="14161C"/>
-                </a:solidFill>
-                <a:latin typeface="Be Vietnam Pro" pitchFamily="34" charset="0"/>
-                <a:ea typeface="Be Vietnam Pro" pitchFamily="34" charset="-122"/>
-                <a:cs typeface="Be Vietnam Pro" pitchFamily="34" charset="-120"/>
-              </a:rPr>
-              <a:t> sở</a:t>
-            </a:r>
-            <a:r>
-              <a:rPr lang="en-US" sz="2700" b="1" dirty="0" spc="30" kern="0">
-                <a:solidFill>
-                  <a:srgbClr val="14161C"/>
-                </a:solidFill>
-                <a:latin typeface="Be Vietnam Pro" pitchFamily="34" charset="0"/>
-                <a:ea typeface="Be Vietnam Pro" pitchFamily="34" charset="-122"/>
-                <a:cs typeface="Be Vietnam Pro" pitchFamily="34" charset="-120"/>
-              </a:rPr>
-              <a:t> hữu:</a:t>
+              <a:t> thuộc</a:t>
+            </a:r>
+            <a:r>
+              <a:rPr lang="en-US" sz="2700" b="1" dirty="0" spc="11" kern="0">
+                <a:solidFill>
+                  <a:srgbClr val="14161C"/>
+                </a:solidFill>
+                <a:latin typeface="Be Vietnam Pro" pitchFamily="34" charset="0"/>
+                <a:ea typeface="Be Vietnam Pro" pitchFamily="34" charset="-122"/>
+                <a:cs typeface="Be Vietnam Pro" pitchFamily="34" charset="-120"/>
+              </a:rPr>
+              <a:t> người</a:t>
             </a:r>
             <a:r>
               <a:rPr lang="en-US" sz="2700" b="1" dirty="0" spc="-1" kern="0">
-                <a:solidFill>
-                  <a:srgbClr val="14161C"/>
-                </a:solidFill>
-                <a:latin typeface="Be Vietnam Pro" pitchFamily="34" charset="0"/>
-                <a:ea typeface="Be Vietnam Pro" pitchFamily="34" charset="-122"/>
-                <a:cs typeface="Be Vietnam Pro" pitchFamily="34" charset="-120"/>
-              </a:rPr>
-              <a:t> dữ</a:t>
-            </a:r>
-            <a:r>
-              <a:rPr lang="en-US" sz="2700" b="1" dirty="0" spc="1" kern="0">
-                <a:solidFill>
-                  <a:srgbClr val="14161C"/>
-                </a:solidFill>
-                <a:latin typeface="Be Vietnam Pro" pitchFamily="34" charset="0"/>
-                <a:ea typeface="Be Vietnam Pro" pitchFamily="34" charset="-122"/>
-                <a:cs typeface="Be Vietnam Pro" pitchFamily="34" charset="-120"/>
-              </a:rPr>
-              <a:t> liệu</a:t>
-            </a:r>
-            <a:r>
-              <a:rPr lang="en-US" sz="2700" b="1" dirty="0" spc="-3" kern="0">
-                <a:solidFill>
-                  <a:srgbClr val="14161C"/>
-                </a:solidFill>
-                <a:latin typeface="Be Vietnam Pro" pitchFamily="34" charset="0"/>
-                <a:ea typeface="Be Vietnam Pro" pitchFamily="34" charset="-122"/>
-                <a:cs typeface="Be Vietnam Pro" pitchFamily="34" charset="-120"/>
-              </a:rPr>
-              <a:t> thuộc</a:t>
-            </a:r>
-            <a:r>
-              <a:rPr lang="en-US" sz="2700" b="1" dirty="0" spc="11" kern="0">
-                <a:solidFill>
-                  <a:srgbClr val="14161C"/>
-                </a:solidFill>
-                <a:latin typeface="Be Vietnam Pro" pitchFamily="34" charset="0"/>
-                <a:ea typeface="Be Vietnam Pro" pitchFamily="34" charset="-122"/>
-                <a:cs typeface="Be Vietnam Pro" pitchFamily="34" charset="-120"/>
-              </a:rPr>
-              <a:t> người</a:t>
-            </a:r>
-            <a:r>
-              <a:rPr lang="en-US" sz="2700" b="1" dirty="0" spc="-2" kern="0">
                 <a:solidFill>
                   <a:srgbClr val="14161C"/>
                 </a:solidFill>
@@ -8812,7 +8812,7 @@
               <a:buNone/>
             </a:pPr>
             <a:r>
-              <a:rPr lang="en-US" sz="6900" dirty="0" spc="-3" kern="0">
+              <a:rPr lang="en-US" sz="6900" dirty="0" spc="6" kern="0">
                 <a:solidFill>
                   <a:srgbClr val="14161C"/>
                 </a:solidFill>
@@ -8820,10 +8820,10 @@
                 <a:ea typeface="Bricolage Grotesque ExtraBold" pitchFamily="34" charset="-122"/>
                 <a:cs typeface="Bricolage Grotesque ExtraBold" pitchFamily="34" charset="-120"/>
               </a:rPr>
-              <a:t>Ứng</a:t>
-            </a:r>
-            <a:r>
-              <a:rPr lang="en-US" sz="6900" dirty="0" spc="2" kern="0">
+              <a:t>Ý</a:t>
+            </a:r>
+            <a:r>
+              <a:rPr lang="en-US" sz="6900" dirty="0" spc="-59" kern="0">
                 <a:solidFill>
                   <a:srgbClr val="14161C"/>
                 </a:solidFill>
@@ -8831,10 +8831,10 @@
                 <a:ea typeface="Bricolage Grotesque ExtraBold" pitchFamily="34" charset="-122"/>
                 <a:cs typeface="Bricolage Grotesque ExtraBold" pitchFamily="34" charset="-120"/>
               </a:rPr>
-              <a:t> dụng</a:t>
-            </a:r>
-            <a:r>
-              <a:rPr lang="en-US" sz="6900" dirty="0" spc="4" kern="0">
+              <a:t> tưởng:</a:t>
+            </a:r>
+            <a:r>
+              <a:rPr lang="en-US" sz="6900" dirty="0" spc="0" kern="0">
                 <a:solidFill>
                   <a:srgbClr val="14161C"/>
                 </a:solidFill>
@@ -8842,10 +8842,10 @@
                 <a:ea typeface="Bricolage Grotesque ExtraBold" pitchFamily="34" charset="-122"/>
                 <a:cs typeface="Bricolage Grotesque ExtraBold" pitchFamily="34" charset="-120"/>
               </a:rPr>
-              <a:t> phải</a:t>
-            </a:r>
-            <a:r>
-              <a:rPr lang="en-US" sz="6900" dirty="0" spc="1" kern="0">
+              <a:t> xin</a:t>
+            </a:r>
+            <a:r>
+              <a:rPr lang="en-US" sz="6900" dirty="0" spc="-5" kern="0">
                 <a:solidFill>
                   <a:srgbClr val="14161C"/>
                 </a:solidFill>
@@ -8853,10 +8853,10 @@
                 <a:ea typeface="Bricolage Grotesque ExtraBold" pitchFamily="34" charset="-122"/>
                 <a:cs typeface="Bricolage Grotesque ExtraBold" pitchFamily="34" charset="-120"/>
               </a:rPr>
-              <a:t> xin</a:t>
-            </a:r>
-            <a:r>
-              <a:rPr lang="en-US" sz="6900" dirty="0" spc="-5" kern="0">
+              <a:t> phép,</a:t>
+            </a:r>
+            <a:r>
+              <a:rPr lang="en-US" sz="6900" dirty="0" spc="-30" kern="0">
                 <a:solidFill>
                   <a:srgbClr val="14161C"/>
                 </a:solidFill>
@@ -8864,21 +8864,10 @@
                 <a:ea typeface="Bricolage Grotesque ExtraBold" pitchFamily="34" charset="-122"/>
                 <a:cs typeface="Bricolage Grotesque ExtraBold" pitchFamily="34" charset="-120"/>
               </a:rPr>
-              <a:t> phép,</a:t>
-            </a:r>
-            <a:r>
-              <a:rPr lang="en-US" sz="6900" dirty="0" spc="-30" kern="0">
-                <a:solidFill>
-                  <a:srgbClr val="14161C"/>
-                </a:solidFill>
-                <a:latin typeface="Bricolage Grotesque ExtraBold" pitchFamily="34" charset="0"/>
-                <a:ea typeface="Bricolage Grotesque ExtraBold" pitchFamily="34" charset="-122"/>
-                <a:cs typeface="Bricolage Grotesque ExtraBold" pitchFamily="34" charset="-120"/>
-              </a:rPr>
               <a:t> trả</a:t>
             </a:r>
             <a:r>
-              <a:rPr lang="en-US" sz="6900" dirty="0" spc="5" kern="0">
+              <a:rPr lang="en-US" sz="6900" dirty="0" spc="6" kern="0">
                 <a:solidFill>
                   <a:srgbClr val="14161C"/>
                 </a:solidFill>

</xml_diff>